<commit_message>
Add combined decoder, hosting, readout comparison; run.sh decoder entry; docs and uv lock update
Co-authored-by: Copilot <223556219+Copilot@users.noreply.github.com>
</commit_message>
<xml_diff>
--- a/docs/Decoder_Tool_Presentation.pptx
+++ b/docs/Decoder_Tool_Presentation.pptx
@@ -7833,7 +7833,7 @@
                 </a:solidFill>
                 <a:latin typeface="Calibri"/>
               </a:rPr>
-              <a:t>•  Compare two readouts of the same VIN</a:t>
+              <a:t>•  Compare readouts of different VINs</a:t>
             </a:r>
           </a:p>
           <a:p>
@@ -9925,6 +9925,23 @@
                 <a:latin typeface="Calibri"/>
               </a:rPr>
               <a:t>Sections, trees and expanders start collapsed; tables word-wrap</a:t>
+            </a:r>
+          </a:p>
+          <a:p>
+            <a:pPr marL="274320" indent="-256032">
+              <a:spcAft>
+                <a:spcPts val="800"/>
+              </a:spcAft>
+              <a:buChar char="•"/>
+            </a:pPr>
+            <a:r>
+              <a:rPr sz="1600">
+                <a:solidFill>
+                  <a:srgbClr val="1F2933"/>
+                </a:solidFill>
+                <a:latin typeface="Calibri"/>
+              </a:rPr>
+              <a:t>A fourth tab, Compare readouts, lists what changed between two readouts of the same VIN, node by node</a:t>
             </a:r>
           </a:p>
         </p:txBody>

</xml_diff>